<commit_message>
ciberescudo: entregables con la ampliación de Convivencia
Documentación técnica, guion, pitch (148 palabras) y bitácora (entrada 13)
actualizados con bullying, ciberacoso y convivencia escolar.

Co-Authored-By: Claude Opus 5.5 <noreply@anthropic.com>
Claude-Session: https://claude.ai/code/session_017mGPQDWJF6quXgxpQqh3gs
</commit_message>
<xml_diff>
--- a/ciberescudo/entregables/GUION.pptx
+++ b/ciberescudo/entregables/GUION.pptx
@@ -116,14 +116,14 @@
   <p:extLst>
     <p:ext uri="{521415D9-36F7-43E2-AB2F-B90AF26B5E84}">
       <p14:sectionLst xmlns:p14="http://schemas.microsoft.com/office/powerpoint/2010/main">
-        <p14:section name="Introducción" id="{265a4772-cced-c417-74b1-972f4a8cf96b}">
+        <p14:section name="Introducción" id="{b8634737-a17d-a75c-399e-a87140e0c3a6}">
           <p14:sldIdLst>
             <p14:sldId id="256"/>
             <p14:sldId id="257"/>
             <p14:sldId id="258"/>
           </p14:sldIdLst>
         </p14:section>
-        <p14:section name="Producto" id="{fd4e9312-6b59-3151-ad6b-57e29fa1d5be}">
+        <p14:section name="Producto" id="{0c384f8a-f511-cfc4-1b4a-7a57e69a77ac}">
           <p14:sldIdLst>
             <p14:sldId id="259"/>
             <p14:sldId id="260"/>
@@ -131,13 +131,13 @@
             <p14:sldId id="262"/>
           </p14:sldIdLst>
         </p14:section>
-        <p14:section name="Técnica" id="{8661d5e5-0bd2-ce33-5139-34fe0da1d857}">
+        <p14:section name="Técnica" id="{0d0309e3-eb2c-461f-1823-f8dc8d6acdcf}">
           <p14:sldIdLst>
             <p14:sldId id="263"/>
             <p14:sldId id="264"/>
           </p14:sldIdLst>
         </p14:section>
-        <p14:section name="Cierre" id="{a788b2f6-8792-7f0e-5d23-ec5283fa62c8}">
+        <p14:section name="Cierre" id="{37ce558b-b9bb-f4fa-ecd5-f94d1e230fa0}">
           <p14:sldIdLst>
             <p14:sldId id="265"/>
           </p14:sldIdLst>
@@ -722,7 +722,7 @@
           <a:p>
             <a:r>
               <a:rPr lang="en-US" dirty="0"/>
-              <a:t>Explicar los cuatro problemas que vive la escuela. Remarcar que no es culpa de las víctimas: son trampas diseñadas para engañar a cualquiera. Duración: 1 minuto.</a:t>
+              <a:t>Explicar los seis problemas: cuatro de seguridad digital y dos de convivencia (bullying y ciberacoso). Remarcar que nunca es culpa de las víctimas. Duración: 1 minuto.</a:t>
             </a:r>
             <a:endParaRPr lang="en-US" dirty="0"/>
           </a:p>
@@ -810,7 +810,7 @@
           <a:p>
             <a:r>
               <a:rPr lang="en-US" dirty="0"/>
-              <a:t>La app se organiza en tres ideas: aprender, practicar y actuar. Mencionar que funciona sin internet y no pide cuentas ni datos. Duración: 1 minuto.</a:t>
+              <a:t>La app se organiza en tres ideas: aprender, practicar y actuar, para la seguridad digital y para la convivencia (en línea y en persona). Mencionar que funciona sin internet y no pide cuentas ni datos. Duración: 1 minuto.</a:t>
             </a:r>
             <a:endParaRPr lang="en-US" dirty="0"/>
           </a:p>
@@ -1074,7 +1074,7 @@
           <a:p>
             <a:r>
               <a:rPr lang="en-US" dirty="0"/>
-              <a:t>Demo en vivo: tocar la flor para que cante; contestar un escenario del simulador y ver cómo celebra la mascota; mostrar los 3 mundos de retos. En Plan de acción, crear, editar, marcar y borrar una tarea y recargar para demostrar que se guardó. Abrir «Más → Certificado» para mostrar los requisitos. Duración: 1.5 minutos.</a:t>
+              <a:t>Demo en vivo: tocar la flor para que cante; contestar un escenario del simulador y ver cómo celebra la mascota; abrir «Más → Convivencia» y mostrar los 3 pasos (en línea y en persona) y un escenario del paquete «En la escuela». En Plan de acción, crear, editar, marcar y borrar una tarea y recargar para demostrar que se guardó. Abrir «Más → Certificado» para mostrar los requisitos. Duración: 1.5 minutos.</a:t>
             </a:r>
             <a:endParaRPr lang="en-US" dirty="0"/>
           </a:p>
@@ -2093,7 +2093,7 @@
                 <a:ea typeface="Arial" pitchFamily="34" charset="-122"/>
                 <a:cs typeface="Arial" pitchFamily="34" charset="-120"/>
               </a:rPr>
-              <a:t>App educativa y gamificada para estudiantes de 15 a 18 años</a:t>
+              <a:t>Seguridad digital y convivencia para estudiantes de 15 a 18 años</a:t>
             </a:r>
             <a:endParaRPr lang="en-US" sz="1400" dirty="0"/>
           </a:p>
@@ -2349,7 +2349,7 @@
       </p:sp>
       <p:pic>
         <p:nvPicPr>
-          <p:cNvPr id="7" name="icono chat" descr="Ícono chat">    </p:cNvPr>
+          <p:cNvPr id="7" name="icono corazon" descr="Ícono corazon">    </p:cNvPr>
           <p:cNvPicPr>
             <a:picLocks noChangeAspect="1"/>
           </p:cNvPicPr>
@@ -2404,7 +2404,7 @@
                 <a:ea typeface="Arial" pitchFamily="34" charset="-122"/>
                 <a:cs typeface="Arial" pitchFamily="34" charset="-120"/>
               </a:rPr>
-              <a:t>Practicar con mensajes falsos prepara para los reales.</a:t>
+              <a:t>La seguridad también es cómo nos tratamos: identificar, prevenir y actuar, en línea y en persona.</a:t>
             </a:r>
             <a:endParaRPr lang="en-US" sz="1500" dirty="0"/>
           </a:p>
@@ -2674,7 +2674,7 @@
         <p:spPr>
           <a:xfrm>
             <a:off x="457200" y="2514600"/>
-            <a:ext cx="2926080" cy="1188720"/>
+            <a:ext cx="2926080" cy="1463040"/>
           </a:xfrm>
           <a:prstGeom prst="rect">
             <a:avLst/>
@@ -2698,7 +2698,7 @@
                 <a:ea typeface="Arial" pitchFamily="34" charset="-122"/>
                 <a:cs typeface="Arial" pitchFamily="34" charset="-120"/>
               </a:rPr>
-              <a:t>estudiantes de 15 a 18 años usan el celular a diario y casi nadie lee una guía de seguridad digital.</a:t>
+              <a:t>estudiantes de 15 a 18 años usan el celular a diario. Los riesgos están en sus cuentas y también en cómo se tratan, en línea y en la escuela.</a:t>
             </a:r>
             <a:endParaRPr lang="en-US" sz="1500" dirty="0"/>
           </a:p>
@@ -2712,8 +2712,8 @@
         </p:nvSpPr>
         <p:spPr>
           <a:xfrm>
-            <a:off x="3904488" y="1344168"/>
-            <a:ext cx="2286000" cy="1371600"/>
+            <a:off x="3904488" y="1252728"/>
+            <a:ext cx="2286000" cy="960120"/>
           </a:xfrm>
           <a:prstGeom prst="rect">
             <a:avLst/>
@@ -2737,8 +2737,8 @@
         </p:nvSpPr>
         <p:spPr>
           <a:xfrm>
-            <a:off x="3840480" y="1280160"/>
-            <a:ext cx="2286000" cy="1371600"/>
+            <a:off x="3840480" y="1188720"/>
+            <a:ext cx="2286000" cy="960120"/>
           </a:xfrm>
           <a:prstGeom prst="rect">
             <a:avLst/>
@@ -2770,8 +2770,8 @@
         </p:blipFill>
         <p:spPr>
           <a:xfrm>
-            <a:off x="4023360" y="1463040"/>
-            <a:ext cx="411480" cy="411480"/>
+            <a:off x="4005072" y="1353312"/>
+            <a:ext cx="365760" cy="365760"/>
           </a:xfrm>
           <a:prstGeom prst="rect">
             <a:avLst/>
@@ -2786,8 +2786,8 @@
         </p:nvSpPr>
         <p:spPr>
           <a:xfrm>
-            <a:off x="4023360" y="1965960"/>
-            <a:ext cx="1965960" cy="320040"/>
+            <a:off x="4480560" y="1325880"/>
+            <a:ext cx="1554480" cy="365760"/>
           </a:xfrm>
           <a:prstGeom prst="rect">
             <a:avLst/>
@@ -2796,7 +2796,7 @@
           <a:ln/>
         </p:spPr>
         <p:txBody>
-          <a:bodyPr wrap="square" lIns="0" tIns="0" rIns="0" bIns="0" rtlCol="0" anchor="t"/>
+          <a:bodyPr wrap="square" lIns="0" tIns="0" rIns="0" bIns="0" rtlCol="0" anchor="ctr"/>
           <a:lstStyle/>
           <a:p>
             <a:pPr indent="0" marL="0">
@@ -2825,8 +2825,8 @@
         </p:nvSpPr>
         <p:spPr>
           <a:xfrm>
-            <a:off x="4023360" y="2258568"/>
-            <a:ext cx="1965960" cy="274320"/>
+            <a:off x="4005072" y="1783080"/>
+            <a:ext cx="2011680" cy="274320"/>
           </a:xfrm>
           <a:prstGeom prst="rect">
             <a:avLst/>
@@ -2864,8 +2864,8 @@
         </p:nvSpPr>
         <p:spPr>
           <a:xfrm>
-            <a:off x="6419088" y="1344168"/>
-            <a:ext cx="2286000" cy="1371600"/>
+            <a:off x="6419088" y="1252728"/>
+            <a:ext cx="2286000" cy="960120"/>
           </a:xfrm>
           <a:prstGeom prst="rect">
             <a:avLst/>
@@ -2889,8 +2889,8 @@
         </p:nvSpPr>
         <p:spPr>
           <a:xfrm>
-            <a:off x="6355080" y="1280160"/>
-            <a:ext cx="2286000" cy="1371600"/>
+            <a:off x="6355080" y="1188720"/>
+            <a:ext cx="2286000" cy="960120"/>
           </a:xfrm>
           <a:prstGeom prst="rect">
             <a:avLst/>
@@ -2922,8 +2922,8 @@
         </p:blipFill>
         <p:spPr>
           <a:xfrm>
-            <a:off x="6537960" y="1463040"/>
-            <a:ext cx="411480" cy="411480"/>
+            <a:off x="6519672" y="1353312"/>
+            <a:ext cx="365760" cy="365760"/>
           </a:xfrm>
           <a:prstGeom prst="rect">
             <a:avLst/>
@@ -2938,8 +2938,8 @@
         </p:nvSpPr>
         <p:spPr>
           <a:xfrm>
-            <a:off x="6537960" y="1965960"/>
-            <a:ext cx="1965960" cy="320040"/>
+            <a:off x="6995160" y="1325880"/>
+            <a:ext cx="1554480" cy="365760"/>
           </a:xfrm>
           <a:prstGeom prst="rect">
             <a:avLst/>
@@ -2948,7 +2948,7 @@
           <a:ln/>
         </p:spPr>
         <p:txBody>
-          <a:bodyPr wrap="square" lIns="0" tIns="0" rIns="0" bIns="0" rtlCol="0" anchor="t"/>
+          <a:bodyPr wrap="square" lIns="0" tIns="0" rIns="0" bIns="0" rtlCol="0" anchor="ctr"/>
           <a:lstStyle/>
           <a:p>
             <a:pPr indent="0" marL="0">
@@ -2977,8 +2977,8 @@
         </p:nvSpPr>
         <p:spPr>
           <a:xfrm>
-            <a:off x="6537960" y="2258568"/>
-            <a:ext cx="1965960" cy="274320"/>
+            <a:off x="6519672" y="1783080"/>
+            <a:ext cx="2011680" cy="274320"/>
           </a:xfrm>
           <a:prstGeom prst="rect">
             <a:avLst/>
@@ -3016,8 +3016,8 @@
         </p:nvSpPr>
         <p:spPr>
           <a:xfrm>
-            <a:off x="3904488" y="2944368"/>
-            <a:ext cx="2286000" cy="1371600"/>
+            <a:off x="3904488" y="2350008"/>
+            <a:ext cx="2286000" cy="960120"/>
           </a:xfrm>
           <a:prstGeom prst="rect">
             <a:avLst/>
@@ -3041,8 +3041,8 @@
         </p:nvSpPr>
         <p:spPr>
           <a:xfrm>
-            <a:off x="3840480" y="2880360"/>
-            <a:ext cx="2286000" cy="1371600"/>
+            <a:off x="3840480" y="2286000"/>
+            <a:ext cx="2286000" cy="960120"/>
           </a:xfrm>
           <a:prstGeom prst="rect">
             <a:avLst/>
@@ -3074,8 +3074,8 @@
         </p:blipFill>
         <p:spPr>
           <a:xfrm>
-            <a:off x="4023360" y="3063240"/>
-            <a:ext cx="411480" cy="411480"/>
+            <a:off x="4005072" y="2450592"/>
+            <a:ext cx="365760" cy="365760"/>
           </a:xfrm>
           <a:prstGeom prst="rect">
             <a:avLst/>
@@ -3090,8 +3090,8 @@
         </p:nvSpPr>
         <p:spPr>
           <a:xfrm>
-            <a:off x="4023360" y="3566160"/>
-            <a:ext cx="1965960" cy="320040"/>
+            <a:off x="4480560" y="2423160"/>
+            <a:ext cx="1554480" cy="365760"/>
           </a:xfrm>
           <a:prstGeom prst="rect">
             <a:avLst/>
@@ -3100,7 +3100,7 @@
           <a:ln/>
         </p:spPr>
         <p:txBody>
-          <a:bodyPr wrap="square" lIns="0" tIns="0" rIns="0" bIns="0" rtlCol="0" anchor="t"/>
+          <a:bodyPr wrap="square" lIns="0" tIns="0" rIns="0" bIns="0" rtlCol="0" anchor="ctr"/>
           <a:lstStyle/>
           <a:p>
             <a:pPr indent="0" marL="0">
@@ -3129,8 +3129,8 @@
         </p:nvSpPr>
         <p:spPr>
           <a:xfrm>
-            <a:off x="4023360" y="3858768"/>
-            <a:ext cx="1965960" cy="274320"/>
+            <a:off x="4005072" y="2880360"/>
+            <a:ext cx="2011680" cy="274320"/>
           </a:xfrm>
           <a:prstGeom prst="rect">
             <a:avLst/>
@@ -3168,8 +3168,8 @@
         </p:nvSpPr>
         <p:spPr>
           <a:xfrm>
-            <a:off x="6419088" y="2944368"/>
-            <a:ext cx="2286000" cy="1371600"/>
+            <a:off x="6419088" y="2350008"/>
+            <a:ext cx="2286000" cy="960120"/>
           </a:xfrm>
           <a:prstGeom prst="rect">
             <a:avLst/>
@@ -3193,8 +3193,8 @@
         </p:nvSpPr>
         <p:spPr>
           <a:xfrm>
-            <a:off x="6355080" y="2880360"/>
-            <a:ext cx="2286000" cy="1371600"/>
+            <a:off x="6355080" y="2286000"/>
+            <a:ext cx="2286000" cy="960120"/>
           </a:xfrm>
           <a:prstGeom prst="rect">
             <a:avLst/>
@@ -3226,8 +3226,8 @@
         </p:blipFill>
         <p:spPr>
           <a:xfrm>
-            <a:off x="6537960" y="3063240"/>
-            <a:ext cx="411480" cy="411480"/>
+            <a:off x="6519672" y="2450592"/>
+            <a:ext cx="365760" cy="365760"/>
           </a:xfrm>
           <a:prstGeom prst="rect">
             <a:avLst/>
@@ -3242,8 +3242,8 @@
         </p:nvSpPr>
         <p:spPr>
           <a:xfrm>
-            <a:off x="6537960" y="3566160"/>
-            <a:ext cx="1965960" cy="320040"/>
+            <a:off x="6995160" y="2423160"/>
+            <a:ext cx="1554480" cy="365760"/>
           </a:xfrm>
           <a:prstGeom prst="rect">
             <a:avLst/>
@@ -3252,7 +3252,7 @@
           <a:ln/>
         </p:spPr>
         <p:txBody>
-          <a:bodyPr wrap="square" lIns="0" tIns="0" rIns="0" bIns="0" rtlCol="0" anchor="t"/>
+          <a:bodyPr wrap="square" lIns="0" tIns="0" rIns="0" bIns="0" rtlCol="0" anchor="ctr"/>
           <a:lstStyle/>
           <a:p>
             <a:pPr indent="0" marL="0">
@@ -3281,8 +3281,8 @@
         </p:nvSpPr>
         <p:spPr>
           <a:xfrm>
-            <a:off x="6537960" y="3858768"/>
-            <a:ext cx="1965960" cy="274320"/>
+            <a:off x="6519672" y="2880360"/>
+            <a:ext cx="2011680" cy="274320"/>
           </a:xfrm>
           <a:prstGeom prst="rect">
             <a:avLst/>
@@ -3306,7 +3306,311 @@
                 <a:ea typeface="Arial" pitchFamily="34" charset="-122"/>
                 <a:cs typeface="Arial" pitchFamily="34" charset="-120"/>
               </a:rPr>
-              <a:t>Se difunden sin consentimiento</a:t>
+              <a:t>Fotos, stickers y videos</a:t>
+            </a:r>
+            <a:endParaRPr lang="en-US" sz="1100" dirty="0"/>
+          </a:p>
+        </p:txBody>
+      </p:sp>
+      <p:sp>
+        <p:nvSpPr>
+          <p:cNvPr id="25" name="problema Bullying sombra"/>
+          <p:cNvSpPr/>
+          <p:nvPr/>
+        </p:nvSpPr>
+        <p:spPr>
+          <a:xfrm>
+            <a:off x="3904488" y="3447288"/>
+            <a:ext cx="2286000" cy="960120"/>
+          </a:xfrm>
+          <a:prstGeom prst="rect">
+            <a:avLst/>
+          </a:prstGeom>
+          <a:solidFill>
+            <a:schemeClr val="accent4"/>
+          </a:solidFill>
+          <a:ln w="12700">
+            <a:solidFill>
+              <a:schemeClr val="accent4"/>
+            </a:solidFill>
+            <a:prstDash val="solid"/>
+          </a:ln>
+        </p:spPr>
+      </p:sp>
+      <p:sp>
+        <p:nvSpPr>
+          <p:cNvPr id="26" name="problema Bullying"/>
+          <p:cNvSpPr/>
+          <p:nvPr/>
+        </p:nvSpPr>
+        <p:spPr>
+          <a:xfrm>
+            <a:off x="3840480" y="3383280"/>
+            <a:ext cx="2286000" cy="960120"/>
+          </a:xfrm>
+          <a:prstGeom prst="rect">
+            <a:avLst/>
+          </a:prstGeom>
+          <a:solidFill>
+            <a:schemeClr val="tx2"/>
+          </a:solidFill>
+          <a:ln w="25400">
+            <a:solidFill>
+              <a:schemeClr val="accent4"/>
+            </a:solidFill>
+            <a:prstDash val="solid"/>
+          </a:ln>
+        </p:spPr>
+      </p:sp>
+      <p:pic>
+        <p:nvPicPr>
+          <p:cNvPr id="27" name="icono corazon" descr="Ícono corazon">    </p:cNvPr>
+          <p:cNvPicPr>
+            <a:picLocks noChangeAspect="1"/>
+          </p:cNvPicPr>
+          <p:nvPr/>
+        </p:nvPicPr>
+        <p:blipFill>
+          <a:blip r:embed="rId5"/>
+          <a:stretch>
+            <a:fillRect/>
+          </a:stretch>
+        </p:blipFill>
+        <p:spPr>
+          <a:xfrm>
+            <a:off x="4005072" y="3547872"/>
+            <a:ext cx="365760" cy="365760"/>
+          </a:xfrm>
+          <a:prstGeom prst="rect">
+            <a:avLst/>
+          </a:prstGeom>
+        </p:spPr>
+      </p:pic>
+      <p:sp>
+        <p:nvSpPr>
+          <p:cNvPr id="28" name="Text 21"/>
+          <p:cNvSpPr txBox="1"/>
+          <p:nvPr/>
+        </p:nvSpPr>
+        <p:spPr>
+          <a:xfrm>
+            <a:off x="4480560" y="3520440"/>
+            <a:ext cx="1554480" cy="365760"/>
+          </a:xfrm>
+          <a:prstGeom prst="rect">
+            <a:avLst/>
+          </a:prstGeom>
+          <a:noFill/>
+          <a:ln/>
+        </p:spPr>
+        <p:txBody>
+          <a:bodyPr wrap="square" lIns="0" tIns="0" rIns="0" bIns="0" rtlCol="0" anchor="ctr"/>
+          <a:lstStyle/>
+          <a:p>
+            <a:pPr indent="0" marL="0">
+              <a:buNone/>
+            </a:pPr>
+            <a:r>
+              <a:rPr lang="en-US" sz="1300" b="1" dirty="0">
+                <a:solidFill>
+                  <a:schemeClr val="bg2"/>
+                </a:solidFill>
+                <a:latin typeface="Courier New" pitchFamily="34" charset="0"/>
+                <a:ea typeface="Courier New" pitchFamily="34" charset="-122"/>
+                <a:cs typeface="Courier New" pitchFamily="34" charset="-120"/>
+              </a:rPr>
+              <a:t>Bullying</a:t>
+            </a:r>
+            <a:endParaRPr lang="en-US" sz="1300" dirty="0"/>
+          </a:p>
+        </p:txBody>
+      </p:sp>
+      <p:sp>
+        <p:nvSpPr>
+          <p:cNvPr id="29" name="Text 22"/>
+          <p:cNvSpPr txBox="1"/>
+          <p:nvPr/>
+        </p:nvSpPr>
+        <p:spPr>
+          <a:xfrm>
+            <a:off x="4005072" y="3977640"/>
+            <a:ext cx="2011680" cy="274320"/>
+          </a:xfrm>
+          <a:prstGeom prst="rect">
+            <a:avLst/>
+          </a:prstGeom>
+          <a:noFill/>
+          <a:ln/>
+        </p:spPr>
+        <p:txBody>
+          <a:bodyPr wrap="square" lIns="0" tIns="0" rIns="0" bIns="0" rtlCol="0" anchor="t"/>
+          <a:lstStyle/>
+          <a:p>
+            <a:pPr indent="0" marL="0">
+              <a:buNone/>
+            </a:pPr>
+            <a:r>
+              <a:rPr lang="en-US" sz="1100" dirty="0">
+                <a:solidFill>
+                  <a:schemeClr val="accent6"/>
+                </a:solidFill>
+                <a:latin typeface="Arial" pitchFamily="34" charset="0"/>
+                <a:ea typeface="Arial" pitchFamily="34" charset="-122"/>
+                <a:cs typeface="Arial" pitchFamily="34" charset="-120"/>
+              </a:rPr>
+              <a:t>Burlas, exclusión y agresiones</a:t>
+            </a:r>
+            <a:endParaRPr lang="en-US" sz="1100" dirty="0"/>
+          </a:p>
+        </p:txBody>
+      </p:sp>
+      <p:sp>
+        <p:nvSpPr>
+          <p:cNvPr id="30" name="problema Ciberacoso sombra"/>
+          <p:cNvSpPr/>
+          <p:nvPr/>
+        </p:nvSpPr>
+        <p:spPr>
+          <a:xfrm>
+            <a:off x="6419088" y="3447288"/>
+            <a:ext cx="2286000" cy="960120"/>
+          </a:xfrm>
+          <a:prstGeom prst="rect">
+            <a:avLst/>
+          </a:prstGeom>
+          <a:solidFill>
+            <a:schemeClr val="accent1"/>
+          </a:solidFill>
+          <a:ln w="12700">
+            <a:solidFill>
+              <a:schemeClr val="accent1"/>
+            </a:solidFill>
+            <a:prstDash val="solid"/>
+          </a:ln>
+        </p:spPr>
+      </p:sp>
+      <p:sp>
+        <p:nvSpPr>
+          <p:cNvPr id="31" name="problema Ciberacoso"/>
+          <p:cNvSpPr/>
+          <p:nvPr/>
+        </p:nvSpPr>
+        <p:spPr>
+          <a:xfrm>
+            <a:off x="6355080" y="3383280"/>
+            <a:ext cx="2286000" cy="960120"/>
+          </a:xfrm>
+          <a:prstGeom prst="rect">
+            <a:avLst/>
+          </a:prstGeom>
+          <a:solidFill>
+            <a:schemeClr val="tx2"/>
+          </a:solidFill>
+          <a:ln w="25400">
+            <a:solidFill>
+              <a:schemeClr val="accent1"/>
+            </a:solidFill>
+            <a:prstDash val="solid"/>
+          </a:ln>
+        </p:spPr>
+      </p:sp>
+      <p:pic>
+        <p:nvPicPr>
+          <p:cNvPr id="32" name="icono corazon" descr="Ícono corazon">    </p:cNvPr>
+          <p:cNvPicPr>
+            <a:picLocks noChangeAspect="1"/>
+          </p:cNvPicPr>
+          <p:nvPr/>
+        </p:nvPicPr>
+        <p:blipFill>
+          <a:blip r:embed="rId6"/>
+          <a:stretch>
+            <a:fillRect/>
+          </a:stretch>
+        </p:blipFill>
+        <p:spPr>
+          <a:xfrm>
+            <a:off x="6519672" y="3547872"/>
+            <a:ext cx="365760" cy="365760"/>
+          </a:xfrm>
+          <a:prstGeom prst="rect">
+            <a:avLst/>
+          </a:prstGeom>
+        </p:spPr>
+      </p:pic>
+      <p:sp>
+        <p:nvSpPr>
+          <p:cNvPr id="33" name="Text 25"/>
+          <p:cNvSpPr txBox="1"/>
+          <p:nvPr/>
+        </p:nvSpPr>
+        <p:spPr>
+          <a:xfrm>
+            <a:off x="6995160" y="3520440"/>
+            <a:ext cx="1554480" cy="365760"/>
+          </a:xfrm>
+          <a:prstGeom prst="rect">
+            <a:avLst/>
+          </a:prstGeom>
+          <a:noFill/>
+          <a:ln/>
+        </p:spPr>
+        <p:txBody>
+          <a:bodyPr wrap="square" lIns="0" tIns="0" rIns="0" bIns="0" rtlCol="0" anchor="ctr"/>
+          <a:lstStyle/>
+          <a:p>
+            <a:pPr indent="0" marL="0">
+              <a:buNone/>
+            </a:pPr>
+            <a:r>
+              <a:rPr lang="en-US" sz="1300" b="1" dirty="0">
+                <a:solidFill>
+                  <a:schemeClr val="bg2"/>
+                </a:solidFill>
+                <a:latin typeface="Courier New" pitchFamily="34" charset="0"/>
+                <a:ea typeface="Courier New" pitchFamily="34" charset="-122"/>
+                <a:cs typeface="Courier New" pitchFamily="34" charset="-120"/>
+              </a:rPr>
+              <a:t>Ciberacoso</a:t>
+            </a:r>
+            <a:endParaRPr lang="en-US" sz="1300" dirty="0"/>
+          </a:p>
+        </p:txBody>
+      </p:sp>
+      <p:sp>
+        <p:nvSpPr>
+          <p:cNvPr id="34" name="Text 26"/>
+          <p:cNvSpPr txBox="1"/>
+          <p:nvPr/>
+        </p:nvSpPr>
+        <p:spPr>
+          <a:xfrm>
+            <a:off x="6519672" y="3977640"/>
+            <a:ext cx="2011680" cy="274320"/>
+          </a:xfrm>
+          <a:prstGeom prst="rect">
+            <a:avLst/>
+          </a:prstGeom>
+          <a:noFill/>
+          <a:ln/>
+        </p:spPr>
+        <p:txBody>
+          <a:bodyPr wrap="square" lIns="0" tIns="0" rIns="0" bIns="0" rtlCol="0" anchor="t"/>
+          <a:lstStyle/>
+          <a:p>
+            <a:pPr indent="0" marL="0">
+              <a:buNone/>
+            </a:pPr>
+            <a:r>
+              <a:rPr lang="en-US" sz="1100" dirty="0">
+                <a:solidFill>
+                  <a:schemeClr val="accent6"/>
+                </a:solidFill>
+                <a:latin typeface="Arial" pitchFamily="34" charset="0"/>
+                <a:ea typeface="Arial" pitchFamily="34" charset="-122"/>
+                <a:cs typeface="Arial" pitchFamily="34" charset="-120"/>
+              </a:rPr>
+              <a:t>Chats, rumores y amenazas</a:t>
             </a:r>
             <a:endParaRPr lang="en-US" sz="1100" dirty="0"/>
           </a:p>
@@ -3576,7 +3880,7 @@
                 <a:ea typeface="Arial" pitchFamily="34" charset="-122"/>
                 <a:cs typeface="Arial" pitchFamily="34" charset="-120"/>
               </a:rPr>
-              <a:t>Guía de privacidad</a:t>
+              <a:t>Guías de privacidad y convivencia</a:t>
             </a:r>
             <a:endParaRPr lang="en-US" sz="1300" dirty="0"/>
           </a:p>
@@ -3774,7 +4078,7 @@
                 <a:ea typeface="Arial" pitchFamily="34" charset="-122"/>
                 <a:cs typeface="Arial" pitchFamily="34" charset="-120"/>
               </a:rPr>
-              <a:t>Simulador: 12 mensajes trampa</a:t>
+              <a:t>Simulador: 30 situaciones</a:t>
             </a:r>
             <a:endParaRPr lang="en-US" sz="1300" dirty="0"/>
           </a:p>
@@ -3795,7 +4099,7 @@
                 <a:ea typeface="Arial" pitchFamily="34" charset="-122"/>
                 <a:cs typeface="Arial" pitchFamily="34" charset="-120"/>
               </a:rPr>
-              <a:t>30 retos en 3 mundos</a:t>
+              <a:t>40 retos en 4 mundos</a:t>
             </a:r>
             <a:endParaRPr lang="en-US" sz="1300" dirty="0"/>
           </a:p>
@@ -3816,7 +4120,7 @@
                 <a:ea typeface="Arial" pitchFamily="34" charset="-122"/>
                 <a:cs typeface="Arial" pitchFamily="34" charset="-120"/>
               </a:rPr>
-              <a:t>Retroalimentación inmediata</a:t>
+              <a:t>Identificar · Prevenir · Actuar</a:t>
             </a:r>
             <a:endParaRPr lang="en-US" sz="1300" dirty="0"/>
           </a:p>
@@ -3993,7 +4297,7 @@
                 <a:ea typeface="Arial" pitchFamily="34" charset="-122"/>
                 <a:cs typeface="Arial" pitchFamily="34" charset="-120"/>
               </a:rPr>
-              <a:t>Tareas personales (sin XP)</a:t>
+              <a:t>10 objetivos de convivencia</a:t>
             </a:r>
             <a:endParaRPr lang="en-US" sz="1300" dirty="0"/>
           </a:p>
@@ -5300,7 +5604,7 @@
       </p:sp>
       <p:sp>
         <p:nvSpPr>
-          <p:cNvPr id="6" name="sombra retos.png"/>
+          <p:cNvPr id="6" name="sombra convivencia.png"/>
           <p:cNvSpPr/>
           <p:nvPr/>
         </p:nvSpPr>
@@ -5325,7 +5629,7 @@
       </p:sp>
       <p:pic>
         <p:nvPicPr>
-          <p:cNvPr id="7" name="captura retos.png" descr="Captura de la app: Retos: 3 mundos">    </p:cNvPr>
+          <p:cNvPr id="7" name="captura convivencia.png" descr="Captura de la app: Convivencia: 3 pasos">    </p:cNvPr>
           <p:cNvPicPr>
             <a:picLocks noChangeAspect="1"/>
           </p:cNvPicPr>
@@ -5380,7 +5684,7 @@
                 <a:ea typeface="Arial" pitchFamily="34" charset="-122"/>
                 <a:cs typeface="Arial" pitchFamily="34" charset="-120"/>
               </a:rPr>
-              <a:t>Retos: 3 mundos</a:t>
+              <a:t>Convivencia: 3 pasos</a:t>
             </a:r>
             <a:endParaRPr lang="en-US" sz="1100" dirty="0"/>
           </a:p>
@@ -6173,7 +6477,7 @@
                 <a:ea typeface="Arial" pitchFamily="34" charset="-122"/>
                 <a:cs typeface="Arial" pitchFamily="34" charset="-120"/>
               </a:rPr>
-              <a:t>el XP tiene tope (670). Al dominar todo se gana el certificado y el rango Maestro.</a:t>
+              <a:t>el XP tiene tope (1000). Al dominar todo se gana el certificado y el rango Maestro.</a:t>
             </a:r>
             <a:endParaRPr lang="en-US" sz="1300" dirty="0"/>
           </a:p>
@@ -6393,7 +6697,7 @@
                 <a:ea typeface="Courier New" pitchFamily="34" charset="-122"/>
                 <a:cs typeface="Courier New" pitchFamily="34" charset="-120"/>
               </a:rPr>
-              <a:t>SPA · 8 secciones</a:t>
+              <a:t>SPA · 9 secciones</a:t>
             </a:r>
             <a:endParaRPr lang="en-US" sz="1400" dirty="0"/>
           </a:p>
@@ -7533,7 +7837,7 @@
                 <a:ea typeface="Arial" pitchFamily="34" charset="-122"/>
                 <a:cs typeface="Arial" pitchFamily="34" charset="-120"/>
               </a:rPr>
-              <a:t>Escribió 62 pruebas automáticas</a:t>
+              <a:t>Escribió 69 pruebas automáticas</a:t>
             </a:r>
             <a:endParaRPr lang="en-US" sz="1300" dirty="0"/>
           </a:p>

</xml_diff>